<commit_message>
v0.9.2: extract author profile from build templates (references)
작성자 이름·전화·이메일·저장 경로를 템플릿에서 분리해 references/profile.json 으로 옮기고, 빌드 시 apply_profile.py 가 치환하도록 변경.

- 신규: apply_profile.py (치환 + 잔존 검사, 값이 비면 exit 2), profile.json (빈 값)
- build_pptx.sh: 슬라이드 작성 직후 unpacked/ppt 전체에 프로필 자동 적용 + 로고 훅(references/logo.png)
- build_kr/en.template.js: 표지 작성자 줄 플레이스홀더 + PROFILE GUARD (미치환 실행 시 중단)
- build_pptx_kr/en.template.py: 표지 작성자, 맺음말 이름·전화·이메일 플레이스홀더
- TEMPLATE.pptx: 레이아웃 5종 하단 크레딧·맺음말 연락처 플레이스홀더, 개인 링크 제거, 표지 로고 자리 비움
- pptx-style-guide.md / docx-build-pipeline.md / copy_to_insights.*: 예시의 실명·연락처·개인 폴더명 일반화

프로필 파일 자동 선택: PROFILE 환경변수 > ./profile.json > references/profile.json
</commit_message>
<xml_diff>
--- a/skills/generate-full-report/references/TEMPLATE.pptx
+++ b/skills/generate-full-report/references/TEMPLATE.pptx
@@ -1664,7 +1664,7 @@
                 <a:cs typeface="Malgun Gothic"/>
                 <a:sym typeface="Malgun Gothic"/>
               </a:rPr>
-              <a:t>- Researched, Written, and Created by DONG HYUNG SHIN(donghyung.shin@gmail.com)</a:t>
+              <a:t>- Researched, Written, and Created by {AUTHOR_EN}({EMAIL})</a:t>
             </a:r>
             <a:endParaRPr sz="600">
               <a:solidFill>
@@ -1831,7 +1831,7 @@
                 <a:cs typeface="Malgun Gothic"/>
                 <a:sym typeface="Malgun Gothic"/>
               </a:rPr>
-              <a:t>- Researched, Written, and Created by DONG HYUNG SHIN(donghyung.shin@gmail.com)</a:t>
+              <a:t>- Researched, Written, and Created by {AUTHOR_EN}({EMAIL})</a:t>
             </a:r>
             <a:endParaRPr sz="600">
               <a:solidFill>
@@ -2248,7 +2248,7 @@
                 <a:cs typeface="Malgun Gothic"/>
                 <a:sym typeface="Malgun Gothic"/>
               </a:rPr>
-              <a:t>- Researched, Written, and Created by DONG HYUNG SHIN(donghyung.shin@gmail.com)</a:t>
+              <a:t>- Researched, Written, and Created by {AUTHOR_EN}({EMAIL})</a:t>
             </a:r>
             <a:endParaRPr sz="600">
               <a:solidFill>
@@ -2403,7 +2403,7 @@
                 <a:cs typeface="Malgun Gothic"/>
                 <a:sym typeface="Malgun Gothic"/>
               </a:rPr>
-              <a:t>- Researched, Written, and Created by DONG HYUNG SHIN(donghyung.shin@gmail.com)</a:t>
+              <a:t>- Researched, Written, and Created by {AUTHOR_EN}({EMAIL})</a:t>
             </a:r>
             <a:endParaRPr sz="600">
               <a:solidFill>
@@ -3406,7 +3406,7 @@
                 <a:cs typeface="Malgun Gothic"/>
                 <a:sym typeface="Malgun Gothic"/>
               </a:rPr>
-              <a:t>- Researched, Written, and Created by DONG HYUNG SHIN(donghyung.shin@gmail.com)</a:t>
+              <a:t>- Researched, Written, and Created by {AUTHOR_EN}({EMAIL})</a:t>
             </a:r>
             <a:endParaRPr sz="600">
               <a:solidFill>
@@ -4879,13 +4879,6 @@
                 <a:ea typeface="Jua"/>
                 <a:cs typeface="Jua"/>
                 <a:sym typeface="Jua"/>
-                <a:hlinkClick r:id="rId3">
-                  <a:extLst>
-                    <a:ext uri="{A12FA001-AC4F-418D-AE19-62706E023703}">
-                      <ahyp:hlinkClr val="tx"/>
-                    </a:ext>
-                  </a:extLst>
-                </a:hlinkClick>
               </a:rPr>
               <a:t>신동</a:t>
             </a:r>
@@ -4898,13 +4891,6 @@
                 <a:ea typeface="Jua"/>
                 <a:cs typeface="Jua"/>
                 <a:sym typeface="Jua"/>
-                <a:hlinkClick r:id="rId4">
-                  <a:extLst>
-                    <a:ext uri="{A12FA001-AC4F-418D-AE19-62706E023703}">
-                      <ahyp:hlinkClr val="tx"/>
-                    </a:ext>
-                  </a:extLst>
-                </a:hlinkClick>
               </a:rPr>
               <a:t>형 인사이트</a:t>
             </a:r>
@@ -5683,7 +5669,7 @@
             </a:pPr>
             <a:r>
               <a:rPr lang="en" sz="1600"/>
-              <a:t>신동형</a:t>
+              <a:t>{AUTHOR_KR}</a:t>
             </a:r>
             <a:endParaRPr sz="1600"/>
           </a:p>
@@ -5702,7 +5688,7 @@
             </a:pPr>
             <a:r>
               <a:rPr lang="en" sz="1600"/>
-              <a:t>010-2202-8761</a:t>
+              <a:t>{PHONE_KR}</a:t>
             </a:r>
             <a:endParaRPr sz="1600"/>
           </a:p>
@@ -5721,7 +5707,7 @@
             </a:pPr>
             <a:r>
               <a:rPr lang="en" sz="1600"/>
-              <a:t>donghyung.shin@gmail.com</a:t>
+              <a:t>{EMAIL}</a:t>
             </a:r>
             <a:endParaRPr sz="1600"/>
           </a:p>

</xml_diff>